<commit_message>
docs(pptx): 技术设计 PPT 微调
</commit_message>
<xml_diff>
--- a/flow-kit-技术设计.pptx
+++ b/flow-kit-技术设计.pptx
@@ -3314,8 +3314,8 @@
         </p:nvSpPr>
         <p:spPr>
           <a:xfrm>
-            <a:off x="457200" y="2560320"/>
-            <a:ext cx="11277295" cy="1097280"/>
+            <a:off x="457200" y="3108960"/>
+            <a:ext cx="11277295" cy="2651760"/>
           </a:xfrm>
           <a:prstGeom prst="rect">
             <a:avLst/>
@@ -3323,18 +3323,18 @@
           <a:noFill/>
         </p:spPr>
         <p:txBody>
-          <a:bodyPr wrap="square" anchor="t">
+          <a:bodyPr wrap="square" anchor="ctr">
             <a:spAutoFit/>
           </a:bodyPr>
           <a:lstStyle/>
           <a:p>
             <a:pPr algn="ctr">
               <a:spcAft>
-                <a:spcPts val="400"/>
-              </a:spcAft>
-            </a:pPr>
-            <a:r>
-              <a:rPr sz="2000" b="0">
+                <a:spcPts val="600"/>
+              </a:spcAft>
+            </a:pPr>
+            <a:r>
+              <a:rPr sz="1500" b="0">
                 <a:solidFill>
                   <a:srgbClr val="1A1A2E"/>
                 </a:solidFill>
@@ -3342,7 +3342,79 @@
                 <a:ea typeface="宋体"/>
                 <a:cs typeface="宋体"/>
               </a:rPr>
-              <a:t>三层架构 · artifact-first · protect-the-weakest · 三层门禁 · 双轮独立审查</a:t>
+              <a:t>① 三层架构与设计理念 — 不是纯 markdown，有 Hook 运行时 + Skill 包装</a:t>
+            </a:r>
+          </a:p>
+          <a:p>
+            <a:pPr algn="ctr">
+              <a:spcAft>
+                <a:spcPts val="600"/>
+              </a:spcAft>
+            </a:pPr>
+            <a:r>
+              <a:rPr sz="1500" b="0">
+                <a:solidFill>
+                  <a:srgbClr val="1A1A2E"/>
+                </a:solidFill>
+                <a:latin typeface="Times New Roman"/>
+                <a:ea typeface="宋体"/>
+                <a:cs typeface="宋体"/>
+              </a:rPr>
+              <a:t>② 基本架构 — 8 阶段流水线 · GO 路由 · .specs 文件体系 · 四角色</a:t>
+            </a:r>
+          </a:p>
+          <a:p>
+            <a:pPr algn="ctr">
+              <a:spcAft>
+                <a:spcPts val="600"/>
+              </a:spcAft>
+            </a:pPr>
+            <a:r>
+              <a:rPr sz="1500" b="0">
+                <a:solidFill>
+                  <a:srgbClr val="1A1A2E"/>
+                </a:solidFill>
+                <a:latin typeface="Times New Roman"/>
+                <a:ea typeface="宋体"/>
+                <a:cs typeface="宋体"/>
+              </a:rPr>
+              <a:t>③ 基本使用 — /flow-go · /flow · 安装 · 10 步工作流</a:t>
+            </a:r>
+          </a:p>
+          <a:p>
+            <a:pPr algn="ctr">
+              <a:spcAft>
+                <a:spcPts val="600"/>
+              </a:spcAft>
+            </a:pPr>
+            <a:r>
+              <a:rPr sz="1500" b="0">
+                <a:solidFill>
+                  <a:srgbClr val="1A1A2E"/>
+                </a:solidFill>
+                <a:latin typeface="Times New Roman"/>
+                <a:ea typeface="宋体"/>
+                <a:cs typeface="宋体"/>
+              </a:rPr>
+              <a:t>④ 基本技术设计 — 三层门禁 · Pipeline Goal · L2/L3 双轮审查</a:t>
+            </a:r>
+          </a:p>
+          <a:p>
+            <a:pPr algn="ctr">
+              <a:spcAft>
+                <a:spcPts val="600"/>
+              </a:spcAft>
+            </a:pPr>
+            <a:r>
+              <a:rPr sz="1500" b="0">
+                <a:solidFill>
+                  <a:srgbClr val="1A1A2E"/>
+                </a:solidFill>
+                <a:latin typeface="Times New Roman"/>
+                <a:ea typeface="宋体"/>
+                <a:cs typeface="宋体"/>
+              </a:rPr>
+              <a:t>⑤ 重要技术细节 — 17 模块 Hook · brooks-lint · 13 ADR</a:t>
             </a:r>
           </a:p>
         </p:txBody>
@@ -3573,7 +3645,7 @@
           <a:noFill/>
         </p:spPr>
         <p:txBody>
-          <a:bodyPr wrap="square" anchor="t">
+          <a:bodyPr wrap="square" anchor="ctr">
             <a:spAutoFit/>
           </a:bodyPr>
           <a:lstStyle/>
@@ -3598,7 +3670,7 @@
           <a:p>
             <a:pPr algn="l" lvl="1">
               <a:spcAft>
-                <a:spcPts val="500"/>
+                <a:spcPts val="700"/>
               </a:spcAft>
             </a:pPr>
             <a:r>
@@ -3613,7 +3685,7 @@
           <a:p>
             <a:pPr algn="l" lvl="1">
               <a:spcAft>
-                <a:spcPts val="500"/>
+                <a:spcPts val="700"/>
               </a:spcAft>
             </a:pPr>
             <a:r>
@@ -3628,7 +3700,7 @@
           <a:p>
             <a:pPr algn="l" lvl="1">
               <a:spcAft>
-                <a:spcPts val="500"/>
+                <a:spcPts val="700"/>
               </a:spcAft>
             </a:pPr>
             <a:r>
@@ -3643,7 +3715,7 @@
           <a:p>
             <a:pPr algn="l" lvl="1">
               <a:spcAft>
-                <a:spcPts val="500"/>
+                <a:spcPts val="700"/>
               </a:spcAft>
             </a:pPr>
             <a:r>
@@ -3658,7 +3730,7 @@
           <a:p>
             <a:pPr algn="l" lvl="1">
               <a:spcAft>
-                <a:spcPts val="500"/>
+                <a:spcPts val="700"/>
               </a:spcAft>
             </a:pPr>
             <a:r>
@@ -3673,7 +3745,7 @@
           <a:p>
             <a:pPr algn="l">
               <a:spcAft>
-                <a:spcPts val="500"/>
+                <a:spcPts val="700"/>
               </a:spcAft>
             </a:pPr>
             <a:r>
@@ -3875,18 +3947,18 @@
           <a:noFill/>
         </p:spPr>
         <p:txBody>
-          <a:bodyPr wrap="square" anchor="t">
+          <a:bodyPr wrap="square" anchor="ctr">
             <a:spAutoFit/>
           </a:bodyPr>
           <a:lstStyle/>
           <a:p>
             <a:pPr algn="l">
               <a:spcAft>
-                <a:spcPts val="500"/>
-              </a:spcAft>
-            </a:pPr>
-            <a:r>
-              <a:rPr sz="1500" b="1">
+                <a:spcPts val="600"/>
+              </a:spcAft>
+            </a:pPr>
+            <a:r>
+              <a:rPr sz="1600" b="1">
                 <a:solidFill>
                   <a:srgbClr val="1F3A5F"/>
                 </a:solidFill>
@@ -3900,7 +3972,7 @@
           <a:p>
             <a:pPr algn="l" lvl="1">
               <a:spcAft>
-                <a:spcPts val="500"/>
+                <a:spcPts val="600"/>
               </a:spcAft>
             </a:pPr>
             <a:r>
@@ -3915,11 +3987,11 @@
           <a:p>
             <a:pPr algn="l">
               <a:spcAft>
-                <a:spcPts val="500"/>
-              </a:spcAft>
-            </a:pPr>
-            <a:r>
-              <a:rPr sz="1500" b="1">
+                <a:spcPts val="600"/>
+              </a:spcAft>
+            </a:pPr>
+            <a:r>
+              <a:rPr sz="1600" b="1">
                 <a:solidFill>
                   <a:srgbClr val="E9A23B"/>
                 </a:solidFill>
@@ -3933,7 +4005,7 @@
           <a:p>
             <a:pPr algn="l" lvl="1">
               <a:spcAft>
-                <a:spcPts val="500"/>
+                <a:spcPts val="600"/>
               </a:spcAft>
             </a:pPr>
             <a:r>
@@ -3948,11 +4020,11 @@
           <a:p>
             <a:pPr algn="l">
               <a:spcAft>
-                <a:spcPts val="500"/>
-              </a:spcAft>
-            </a:pPr>
-            <a:r>
-              <a:rPr sz="1500" b="1">
+                <a:spcPts val="600"/>
+              </a:spcAft>
+            </a:pPr>
+            <a:r>
+              <a:rPr sz="1600" b="1">
                 <a:solidFill>
                   <a:srgbClr val="C7463B"/>
                 </a:solidFill>
@@ -3966,7 +4038,7 @@
           <a:p>
             <a:pPr algn="l" lvl="1">
               <a:spcAft>
-                <a:spcPts val="500"/>
+                <a:spcPts val="600"/>
               </a:spcAft>
             </a:pPr>
             <a:r>
@@ -3981,7 +4053,7 @@
           <a:p>
             <a:pPr algn="l" lvl="1">
               <a:spcAft>
-                <a:spcPts val="500"/>
+                <a:spcPts val="600"/>
               </a:spcAft>
             </a:pPr>
             <a:r>
@@ -4207,14 +4279,14 @@
           <a:noFill/>
         </p:spPr>
         <p:txBody>
-          <a:bodyPr wrap="square" anchor="t">
+          <a:bodyPr wrap="square" anchor="b">
             <a:spAutoFit/>
           </a:bodyPr>
           <a:lstStyle/>
           <a:p>
             <a:pPr algn="l">
               <a:spcAft>
-                <a:spcPts val="500"/>
+                <a:spcPts val="700"/>
               </a:spcAft>
             </a:pPr>
             <a:r>
@@ -4240,7 +4312,7 @@
           <p:nvPr/>
         </p:nvGraphicFramePr>
         <p:xfrm>
-          <a:off x="457200" y="1097280"/>
+          <a:off x="457200" y="2286000"/>
           <a:ext cx="11277293" cy="2926080"/>
         </p:xfrm>
         <a:graphic>
@@ -4996,7 +5068,7 @@
           <a:noFill/>
         </p:spPr>
         <p:txBody>
-          <a:bodyPr wrap="square" anchor="t">
+          <a:bodyPr wrap="square" anchor="ctr">
             <a:spAutoFit/>
           </a:bodyPr>
           <a:lstStyle/>
@@ -5018,7 +5090,7 @@
           <a:p>
             <a:pPr algn="l">
               <a:spcAft>
-                <a:spcPts val="500"/>
+                <a:spcPts val="600"/>
               </a:spcAft>
             </a:pPr>
             <a:r>
@@ -5036,7 +5108,7 @@
           <a:p>
             <a:pPr algn="l" lvl="1">
               <a:spcAft>
-                <a:spcPts val="500"/>
+                <a:spcPts val="600"/>
               </a:spcAft>
             </a:pPr>
             <a:r>
@@ -5054,7 +5126,7 @@
           <a:p>
             <a:pPr algn="l" lvl="1">
               <a:spcAft>
-                <a:spcPts val="500"/>
+                <a:spcPts val="600"/>
               </a:spcAft>
             </a:pPr>
             <a:r>
@@ -5069,7 +5141,7 @@
           <a:p>
             <a:pPr algn="l" lvl="1">
               <a:spcAft>
-                <a:spcPts val="500"/>
+                <a:spcPts val="600"/>
               </a:spcAft>
             </a:pPr>
             <a:r>
@@ -5292,18 +5364,18 @@
           <a:noFill/>
         </p:spPr>
         <p:txBody>
-          <a:bodyPr wrap="square" anchor="t">
+          <a:bodyPr wrap="square" anchor="ctr">
             <a:spAutoFit/>
           </a:bodyPr>
           <a:lstStyle/>
           <a:p>
             <a:pPr algn="l">
               <a:spcAft>
-                <a:spcPts val="500"/>
-              </a:spcAft>
-            </a:pPr>
-            <a:r>
-              <a:rPr sz="1500" b="1">
+                <a:spcPts val="700"/>
+              </a:spcAft>
+            </a:pPr>
+            <a:r>
+              <a:rPr sz="1600" b="1">
                 <a:solidFill>
                   <a:srgbClr val="2E86AB"/>
                 </a:solidFill>
@@ -5317,7 +5389,7 @@
           <a:p>
             <a:pPr algn="l" lvl="1">
               <a:spcAft>
-                <a:spcPts val="500"/>
+                <a:spcPts val="700"/>
               </a:spcAft>
             </a:pPr>
             <a:r>
@@ -5332,7 +5404,7 @@
           <a:p>
             <a:pPr algn="l" lvl="1">
               <a:spcAft>
-                <a:spcPts val="500"/>
+                <a:spcPts val="700"/>
               </a:spcAft>
             </a:pPr>
             <a:r>
@@ -5347,11 +5419,11 @@
           <a:p>
             <a:pPr algn="l">
               <a:spcAft>
-                <a:spcPts val="500"/>
-              </a:spcAft>
-            </a:pPr>
-            <a:r>
-              <a:rPr sz="1500" b="1">
+                <a:spcPts val="700"/>
+              </a:spcAft>
+            </a:pPr>
+            <a:r>
+              <a:rPr sz="1600" b="1">
                 <a:solidFill>
                   <a:srgbClr val="C7463B"/>
                 </a:solidFill>
@@ -5365,7 +5437,7 @@
           <a:p>
             <a:pPr algn="l" lvl="1">
               <a:spcAft>
-                <a:spcPts val="500"/>
+                <a:spcPts val="700"/>
               </a:spcAft>
             </a:pPr>
             <a:r>
@@ -5380,11 +5452,11 @@
           <a:p>
             <a:pPr algn="l">
               <a:spcAft>
-                <a:spcPts val="500"/>
-              </a:spcAft>
-            </a:pPr>
-            <a:r>
-              <a:rPr sz="1500" b="1">
+                <a:spcPts val="700"/>
+              </a:spcAft>
+            </a:pPr>
+            <a:r>
+              <a:rPr sz="1600" b="1">
                 <a:solidFill>
                   <a:srgbClr val="E9A23B"/>
                 </a:solidFill>
@@ -5398,7 +5470,7 @@
           <a:p>
             <a:pPr algn="l">
               <a:spcAft>
-                <a:spcPts val="500"/>
+                <a:spcPts val="700"/>
               </a:spcAft>
             </a:pPr>
             <a:r>
@@ -5600,7 +5672,7 @@
           <a:noFill/>
         </p:spPr>
         <p:txBody>
-          <a:bodyPr wrap="square" anchor="t">
+          <a:bodyPr wrap="square" anchor="ctr">
             <a:spAutoFit/>
           </a:bodyPr>
           <a:lstStyle/>
@@ -5622,11 +5694,11 @@
           <a:p>
             <a:pPr algn="l">
               <a:spcAft>
-                <a:spcPts val="500"/>
-              </a:spcAft>
-            </a:pPr>
-            <a:r>
-              <a:rPr sz="1500" b="1">
+                <a:spcPts val="600"/>
+              </a:spcAft>
+            </a:pPr>
+            <a:r>
+              <a:rPr sz="1600" b="1">
                 <a:solidFill>
                   <a:srgbClr val="1F3A5F"/>
                 </a:solidFill>
@@ -5640,7 +5712,7 @@
           <a:p>
             <a:pPr algn="l" lvl="1">
               <a:spcAft>
-                <a:spcPts val="500"/>
+                <a:spcPts val="600"/>
               </a:spcAft>
             </a:pPr>
             <a:r>
@@ -5655,7 +5727,7 @@
           <a:p>
             <a:pPr algn="l" lvl="1">
               <a:spcAft>
-                <a:spcPts val="500"/>
+                <a:spcPts val="600"/>
               </a:spcAft>
             </a:pPr>
             <a:r>
@@ -5688,11 +5760,11 @@
           <a:p>
             <a:pPr algn="l">
               <a:spcAft>
-                <a:spcPts val="500"/>
-              </a:spcAft>
-            </a:pPr>
-            <a:r>
-              <a:rPr sz="1500" b="1">
+                <a:spcPts val="600"/>
+              </a:spcAft>
+            </a:pPr>
+            <a:r>
+              <a:rPr sz="1600" b="1">
                 <a:solidFill>
                   <a:srgbClr val="C7463B"/>
                 </a:solidFill>
@@ -5706,7 +5778,7 @@
           <a:p>
             <a:pPr algn="l" lvl="1">
               <a:spcAft>
-                <a:spcPts val="500"/>
+                <a:spcPts val="600"/>
               </a:spcAft>
             </a:pPr>
             <a:r>
@@ -5721,7 +5793,7 @@
           <a:p>
             <a:pPr algn="l" lvl="1">
               <a:spcAft>
-                <a:spcPts val="500"/>
+                <a:spcPts val="600"/>
               </a:spcAft>
             </a:pPr>
             <a:r>
@@ -5736,7 +5808,7 @@
           <a:p>
             <a:pPr algn="l" lvl="1">
               <a:spcAft>
-                <a:spcPts val="500"/>
+                <a:spcPts val="600"/>
               </a:spcAft>
             </a:pPr>
             <a:r>
@@ -5774,49 +5846,6 @@
           </a:prstGeom>
         </p:spPr>
       </p:pic>
-      <p:sp>
-        <p:nvSpPr>
-          <p:cNvPr id="7" name="TextBox 6"/>
-          <p:cNvSpPr txBox="1"/>
-          <p:nvPr/>
-        </p:nvSpPr>
-        <p:spPr>
-          <a:xfrm>
-            <a:off x="914400" y="5760720"/>
-            <a:ext cx="7315200" cy="457200"/>
-          </a:xfrm>
-          <a:prstGeom prst="rect">
-            <a:avLst/>
-          </a:prstGeom>
-          <a:noFill/>
-        </p:spPr>
-        <p:txBody>
-          <a:bodyPr wrap="square">
-            <a:spAutoFit/>
-          </a:bodyPr>
-          <a:lstStyle/>
-          <a:p>
-            <a:r>
-              <a:rPr sz="900" b="1">
-                <a:solidFill>
-                  <a:srgbClr val="555555"/>
-                </a:solidFill>
-                <a:latin typeface="Times New Roman"/>
-              </a:rPr>
-              <a:t>🆕 correction 收割策略：</a:t>
-            </a:r>
-            <a:r>
-              <a:rPr sz="900">
-                <a:solidFill>
-                  <a:srgbClr val="555555"/>
-                </a:solidFill>
-                <a:latin typeface="Times New Roman"/>
-              </a:rPr>
-              <a:t>降级写 correction → SessionStart 分类型收割：compliance 自动清除、model-missing 持续提示至配齐、l2-missing 持久化保留。覆盖写优先级 compliance &gt; model-missing（ADR-013）。</a:t>
-            </a:r>
-          </a:p>
-        </p:txBody>
-      </p:sp>
     </p:spTree>
   </p:cSld>
   <p:clrMapOvr>
@@ -6002,7 +6031,7 @@
           <a:noFill/>
         </p:spPr>
         <p:txBody>
-          <a:bodyPr wrap="square" anchor="t">
+          <a:bodyPr wrap="square" anchor="ctr">
             <a:spAutoFit/>
           </a:bodyPr>
           <a:lstStyle/>
@@ -6027,7 +6056,7 @@
           <a:p>
             <a:pPr algn="l">
               <a:spcAft>
-                <a:spcPts val="500"/>
+                <a:spcPts val="700"/>
               </a:spcAft>
             </a:pPr>
             <a:r>
@@ -6045,11 +6074,11 @@
           <a:p>
             <a:pPr algn="l">
               <a:spcAft>
-                <a:spcPts val="500"/>
-              </a:spcAft>
-            </a:pPr>
-            <a:r>
-              <a:rPr sz="1500" b="1">
+                <a:spcPts val="700"/>
+              </a:spcAft>
+            </a:pPr>
+            <a:r>
+              <a:rPr sz="1600" b="1">
                 <a:solidFill>
                   <a:srgbClr val="2E86AB"/>
                 </a:solidFill>
@@ -6063,7 +6092,7 @@
           <a:p>
             <a:pPr algn="l" lvl="1">
               <a:spcAft>
-                <a:spcPts val="500"/>
+                <a:spcPts val="700"/>
               </a:spcAft>
             </a:pPr>
             <a:r>
@@ -6078,11 +6107,11 @@
           <a:p>
             <a:pPr algn="l">
               <a:spcAft>
-                <a:spcPts val="500"/>
-              </a:spcAft>
-            </a:pPr>
-            <a:r>
-              <a:rPr sz="1500" b="1">
+                <a:spcPts val="700"/>
+              </a:spcAft>
+            </a:pPr>
+            <a:r>
+              <a:rPr sz="1600" b="1">
                 <a:solidFill>
                   <a:srgbClr val="2A9D8F"/>
                 </a:solidFill>
@@ -6096,7 +6125,7 @@
           <a:p>
             <a:pPr algn="l" lvl="1">
               <a:spcAft>
-                <a:spcPts val="500"/>
+                <a:spcPts val="700"/>
               </a:spcAft>
             </a:pPr>
             <a:r>
@@ -6111,11 +6140,11 @@
           <a:p>
             <a:pPr algn="l">
               <a:spcAft>
-                <a:spcPts val="500"/>
-              </a:spcAft>
-            </a:pPr>
-            <a:r>
-              <a:rPr sz="1500" b="1">
+                <a:spcPts val="700"/>
+              </a:spcAft>
+            </a:pPr>
+            <a:r>
+              <a:rPr sz="1600" b="1">
                 <a:solidFill>
                   <a:srgbClr val="E9A23B"/>
                 </a:solidFill>
@@ -6129,11 +6158,11 @@
           <a:p>
             <a:pPr algn="l">
               <a:spcAft>
-                <a:spcPts val="500"/>
-              </a:spcAft>
-            </a:pPr>
-            <a:r>
-              <a:rPr sz="1500" b="1">
+                <a:spcPts val="700"/>
+              </a:spcAft>
+            </a:pPr>
+            <a:r>
+              <a:rPr sz="1600" b="1">
                 <a:solidFill>
                   <a:srgbClr val="C7463B"/>
                 </a:solidFill>
@@ -6331,18 +6360,18 @@
           <a:noFill/>
         </p:spPr>
         <p:txBody>
-          <a:bodyPr wrap="square" anchor="t">
+          <a:bodyPr wrap="square" anchor="ctr">
             <a:spAutoFit/>
           </a:bodyPr>
           <a:lstStyle/>
           <a:p>
             <a:pPr algn="l">
               <a:spcAft>
-                <a:spcPts val="500"/>
-              </a:spcAft>
-            </a:pPr>
-            <a:r>
-              <a:rPr sz="1500" b="1">
+                <a:spcPts val="700"/>
+              </a:spcAft>
+            </a:pPr>
+            <a:r>
+              <a:rPr sz="1600" b="1">
                 <a:solidFill>
                   <a:srgbClr val="2E86AB"/>
                 </a:solidFill>
@@ -6356,7 +6385,7 @@
           <a:p>
             <a:pPr algn="l" lvl="1">
               <a:spcAft>
-                <a:spcPts val="500"/>
+                <a:spcPts val="700"/>
               </a:spcAft>
             </a:pPr>
             <a:r>
@@ -6371,11 +6400,11 @@
           <a:p>
             <a:pPr algn="l">
               <a:spcAft>
-                <a:spcPts val="500"/>
-              </a:spcAft>
-            </a:pPr>
-            <a:r>
-              <a:rPr sz="1500" b="1">
+                <a:spcPts val="700"/>
+              </a:spcAft>
+            </a:pPr>
+            <a:r>
+              <a:rPr sz="1600" b="1">
                 <a:solidFill>
                   <a:srgbClr val="2E86AB"/>
                 </a:solidFill>
@@ -6389,7 +6418,7 @@
           <a:p>
             <a:pPr algn="l" lvl="1">
               <a:spcAft>
-                <a:spcPts val="500"/>
+                <a:spcPts val="700"/>
               </a:spcAft>
             </a:pPr>
             <a:r>
@@ -6404,11 +6433,11 @@
           <a:p>
             <a:pPr algn="l">
               <a:spcAft>
-                <a:spcPts val="500"/>
-              </a:spcAft>
-            </a:pPr>
-            <a:r>
-              <a:rPr sz="1500" b="1">
+                <a:spcPts val="700"/>
+              </a:spcAft>
+            </a:pPr>
+            <a:r>
+              <a:rPr sz="1600" b="1">
                 <a:solidFill>
                   <a:srgbClr val="2A9D8F"/>
                 </a:solidFill>
@@ -6422,7 +6451,7 @@
           <a:p>
             <a:pPr algn="l" lvl="1">
               <a:spcAft>
-                <a:spcPts val="500"/>
+                <a:spcPts val="700"/>
               </a:spcAft>
             </a:pPr>
             <a:r>
@@ -6437,7 +6466,7 @@
           <a:p>
             <a:pPr algn="l" lvl="1">
               <a:spcAft>
-                <a:spcPts val="500"/>
+                <a:spcPts val="700"/>
               </a:spcAft>
             </a:pPr>
             <a:r>
@@ -6452,7 +6481,7 @@
           <a:p>
             <a:pPr algn="l" lvl="1">
               <a:spcAft>
-                <a:spcPts val="500"/>
+                <a:spcPts val="700"/>
               </a:spcAft>
             </a:pPr>
             <a:r>
@@ -6467,7 +6496,7 @@
           <a:p>
             <a:pPr algn="l" lvl="1">
               <a:spcAft>
-                <a:spcPts val="500"/>
+                <a:spcPts val="700"/>
               </a:spcAft>
             </a:pPr>
             <a:r>
@@ -6482,7 +6511,7 @@
           <a:p>
             <a:pPr algn="l" lvl="1">
               <a:spcAft>
-                <a:spcPts val="500"/>
+                <a:spcPts val="700"/>
               </a:spcAft>
             </a:pPr>
             <a:r>
@@ -6497,7 +6526,7 @@
           <a:p>
             <a:pPr algn="l" lvl="1">
               <a:spcAft>
-                <a:spcPts val="500"/>
+                <a:spcPts val="700"/>
               </a:spcAft>
             </a:pPr>
             <a:r>
@@ -6696,18 +6725,18 @@
           <a:noFill/>
         </p:spPr>
         <p:txBody>
-          <a:bodyPr wrap="square" anchor="t">
+          <a:bodyPr wrap="square" anchor="ctr">
             <a:spAutoFit/>
           </a:bodyPr>
           <a:lstStyle/>
           <a:p>
             <a:pPr algn="l">
               <a:spcAft>
-                <a:spcPts val="500"/>
-              </a:spcAft>
-            </a:pPr>
-            <a:r>
-              <a:rPr sz="1500" b="1">
+                <a:spcPts val="700"/>
+              </a:spcAft>
+            </a:pPr>
+            <a:r>
+              <a:rPr sz="1600" b="1">
                 <a:solidFill>
                   <a:srgbClr val="2E86AB"/>
                 </a:solidFill>
@@ -6721,7 +6750,7 @@
           <a:p>
             <a:pPr algn="l" lvl="1">
               <a:spcAft>
-                <a:spcPts val="500"/>
+                <a:spcPts val="700"/>
               </a:spcAft>
             </a:pPr>
             <a:r>
@@ -6736,7 +6765,7 @@
           <a:p>
             <a:pPr algn="l" lvl="1">
               <a:spcAft>
-                <a:spcPts val="500"/>
+                <a:spcPts val="700"/>
               </a:spcAft>
             </a:pPr>
             <a:r>
@@ -6751,7 +6780,7 @@
           <a:p>
             <a:pPr algn="l" lvl="1">
               <a:spcAft>
-                <a:spcPts val="500"/>
+                <a:spcPts val="700"/>
               </a:spcAft>
             </a:pPr>
             <a:r>
@@ -6769,11 +6798,11 @@
           <a:p>
             <a:pPr algn="l">
               <a:spcAft>
-                <a:spcPts val="500"/>
-              </a:spcAft>
-            </a:pPr>
-            <a:r>
-              <a:rPr sz="1500" b="1">
+                <a:spcPts val="700"/>
+              </a:spcAft>
+            </a:pPr>
+            <a:r>
+              <a:rPr sz="1600" b="1">
                 <a:solidFill>
                   <a:srgbClr val="E9A23B"/>
                 </a:solidFill>
@@ -6787,7 +6816,7 @@
           <a:p>
             <a:pPr algn="l" lvl="1">
               <a:spcAft>
-                <a:spcPts val="500"/>
+                <a:spcPts val="700"/>
               </a:spcAft>
             </a:pPr>
             <a:r>
@@ -6802,7 +6831,7 @@
           <a:p>
             <a:pPr algn="l" lvl="1">
               <a:spcAft>
-                <a:spcPts val="500"/>
+                <a:spcPts val="700"/>
               </a:spcAft>
             </a:pPr>
             <a:r>
@@ -6817,11 +6846,11 @@
           <a:p>
             <a:pPr algn="l">
               <a:spcAft>
-                <a:spcPts val="500"/>
-              </a:spcAft>
-            </a:pPr>
-            <a:r>
-              <a:rPr sz="1500" b="1">
+                <a:spcPts val="700"/>
+              </a:spcAft>
+            </a:pPr>
+            <a:r>
+              <a:rPr sz="1600" b="1">
                 <a:solidFill>
                   <a:srgbClr val="E9A23B"/>
                 </a:solidFill>
@@ -6835,7 +6864,7 @@
           <a:p>
             <a:pPr algn="l" lvl="1">
               <a:spcAft>
-                <a:spcPts val="500"/>
+                <a:spcPts val="700"/>
               </a:spcAft>
             </a:pPr>
             <a:r>
@@ -6850,7 +6879,7 @@
           <a:p>
             <a:pPr algn="l" lvl="1">
               <a:spcAft>
-                <a:spcPts val="500"/>
+                <a:spcPts val="700"/>
               </a:spcAft>
             </a:pPr>
             <a:r>
@@ -6865,11 +6894,11 @@
           <a:p>
             <a:pPr algn="l">
               <a:spcAft>
-                <a:spcPts val="500"/>
-              </a:spcAft>
-            </a:pPr>
-            <a:r>
-              <a:rPr sz="1500" b="1">
+                <a:spcPts val="700"/>
+              </a:spcAft>
+            </a:pPr>
+            <a:r>
+              <a:rPr sz="1600" b="1">
                 <a:solidFill>
                   <a:srgbClr val="C7463B"/>
                 </a:solidFill>
@@ -6883,7 +6912,7 @@
           <a:p>
             <a:pPr algn="l" lvl="1">
               <a:spcAft>
-                <a:spcPts val="500"/>
+                <a:spcPts val="700"/>
               </a:spcAft>
             </a:pPr>
             <a:r>
@@ -7082,14 +7111,14 @@
           <a:noFill/>
         </p:spPr>
         <p:txBody>
-          <a:bodyPr wrap="square" anchor="t">
+          <a:bodyPr wrap="square" anchor="ctr">
             <a:spAutoFit/>
           </a:bodyPr>
           <a:lstStyle/>
           <a:p>
             <a:pPr algn="l" lvl="1">
               <a:spcAft>
-                <a:spcPts val="500"/>
+                <a:spcPts val="700"/>
               </a:spcAft>
             </a:pPr>
             <a:r>
@@ -7107,7 +7136,7 @@
           <a:p>
             <a:pPr algn="l" lvl="1">
               <a:spcAft>
-                <a:spcPts val="500"/>
+                <a:spcPts val="700"/>
               </a:spcAft>
             </a:pPr>
             <a:r>
@@ -7125,7 +7154,7 @@
           <a:p>
             <a:pPr algn="l" lvl="1">
               <a:spcAft>
-                <a:spcPts val="500"/>
+                <a:spcPts val="700"/>
               </a:spcAft>
             </a:pPr>
             <a:r>
@@ -7143,7 +7172,7 @@
           <a:p>
             <a:pPr algn="l" lvl="1">
               <a:spcAft>
-                <a:spcPts val="500"/>
+                <a:spcPts val="700"/>
               </a:spcAft>
             </a:pPr>
             <a:r>
@@ -7161,7 +7190,7 @@
           <a:p>
             <a:pPr algn="l" lvl="1">
               <a:spcAft>
-                <a:spcPts val="500"/>
+                <a:spcPts val="700"/>
               </a:spcAft>
             </a:pPr>
             <a:r>
@@ -7179,11 +7208,11 @@
           <a:p>
             <a:pPr algn="l">
               <a:spcAft>
-                <a:spcPts val="500"/>
-              </a:spcAft>
-            </a:pPr>
-            <a:r>
-              <a:rPr sz="1500" b="1">
+                <a:spcPts val="700"/>
+              </a:spcAft>
+            </a:pPr>
+            <a:r>
+              <a:rPr sz="1600" b="1">
                 <a:solidFill>
                   <a:srgbClr val="2E86AB"/>
                 </a:solidFill>
@@ -7197,7 +7226,7 @@
           <a:p>
             <a:pPr algn="l" lvl="1">
               <a:spcAft>
-                <a:spcPts val="500"/>
+                <a:spcPts val="700"/>
               </a:spcAft>
             </a:pPr>
             <a:r>
@@ -7212,11 +7241,11 @@
           <a:p>
             <a:pPr algn="l">
               <a:spcAft>
-                <a:spcPts val="500"/>
-              </a:spcAft>
-            </a:pPr>
-            <a:r>
-              <a:rPr sz="1500" b="1">
+                <a:spcPts val="700"/>
+              </a:spcAft>
+            </a:pPr>
+            <a:r>
+              <a:rPr sz="1600" b="1">
                 <a:solidFill>
                   <a:srgbClr val="2A9D8F"/>
                 </a:solidFill>
@@ -7230,7 +7259,7 @@
           <a:p>
             <a:pPr algn="l" lvl="1">
               <a:spcAft>
-                <a:spcPts val="500"/>
+                <a:spcPts val="700"/>
               </a:spcAft>
             </a:pPr>
             <a:r>
@@ -7245,7 +7274,7 @@
           <a:p>
             <a:pPr algn="l" lvl="1">
               <a:spcAft>
-                <a:spcPts val="500"/>
+                <a:spcPts val="700"/>
               </a:spcAft>
             </a:pPr>
             <a:r>
@@ -7444,7 +7473,7 @@
           <a:noFill/>
         </p:spPr>
         <p:txBody>
-          <a:bodyPr wrap="square" anchor="t">
+          <a:bodyPr wrap="square" anchor="ctr">
             <a:spAutoFit/>
           </a:bodyPr>
           <a:lstStyle/>
@@ -7466,11 +7495,11 @@
           <a:p>
             <a:pPr algn="l">
               <a:spcAft>
-                <a:spcPts val="500"/>
-              </a:spcAft>
-            </a:pPr>
-            <a:r>
-              <a:rPr sz="1500" b="1">
+                <a:spcPts val="600"/>
+              </a:spcAft>
+            </a:pPr>
+            <a:r>
+              <a:rPr sz="1600" b="1">
                 <a:solidFill>
                   <a:srgbClr val="1F3A5F"/>
                 </a:solidFill>
@@ -7484,7 +7513,7 @@
           <a:p>
             <a:pPr algn="l" lvl="1">
               <a:spcAft>
-                <a:spcPts val="500"/>
+                <a:spcPts val="600"/>
               </a:spcAft>
             </a:pPr>
             <a:r>
@@ -7499,7 +7528,7 @@
           <a:p>
             <a:pPr algn="l" lvl="1">
               <a:spcAft>
-                <a:spcPts val="500"/>
+                <a:spcPts val="600"/>
               </a:spcAft>
             </a:pPr>
             <a:r>
@@ -7517,11 +7546,11 @@
           <a:p>
             <a:pPr algn="l">
               <a:spcAft>
-                <a:spcPts val="500"/>
-              </a:spcAft>
-            </a:pPr>
-            <a:r>
-              <a:rPr sz="1500" b="1">
+                <a:spcPts val="600"/>
+              </a:spcAft>
+            </a:pPr>
+            <a:r>
+              <a:rPr sz="1600" b="1">
                 <a:solidFill>
                   <a:srgbClr val="2E86AB"/>
                 </a:solidFill>
@@ -7535,7 +7564,7 @@
           <a:p>
             <a:pPr algn="l" lvl="1">
               <a:spcAft>
-                <a:spcPts val="500"/>
+                <a:spcPts val="600"/>
               </a:spcAft>
             </a:pPr>
             <a:r>
@@ -7550,7 +7579,7 @@
           <a:p>
             <a:pPr algn="l" lvl="1">
               <a:spcAft>
-                <a:spcPts val="500"/>
+                <a:spcPts val="600"/>
               </a:spcAft>
             </a:pPr>
             <a:r>
@@ -7565,7 +7594,7 @@
           <a:p>
             <a:pPr algn="l" lvl="1">
               <a:spcAft>
-                <a:spcPts val="500"/>
+                <a:spcPts val="600"/>
               </a:spcAft>
             </a:pPr>
             <a:r>
@@ -7580,11 +7609,11 @@
           <a:p>
             <a:pPr algn="l">
               <a:spcAft>
-                <a:spcPts val="500"/>
-              </a:spcAft>
-            </a:pPr>
-            <a:r>
-              <a:rPr sz="1500" b="1">
+                <a:spcPts val="600"/>
+              </a:spcAft>
+            </a:pPr>
+            <a:r>
+              <a:rPr sz="1600" b="1">
                 <a:solidFill>
                   <a:srgbClr val="2A9D8F"/>
                 </a:solidFill>
@@ -7598,7 +7627,7 @@
           <a:p>
             <a:pPr algn="l" lvl="1">
               <a:spcAft>
-                <a:spcPts val="500"/>
+                <a:spcPts val="600"/>
               </a:spcAft>
             </a:pPr>
             <a:r>
@@ -7613,7 +7642,7 @@
           <a:p>
             <a:pPr algn="l" lvl="1">
               <a:spcAft>
-                <a:spcPts val="500"/>
+                <a:spcPts val="600"/>
               </a:spcAft>
             </a:pPr>
             <a:r>
@@ -7836,18 +7865,18 @@
           <a:noFill/>
         </p:spPr>
         <p:txBody>
-          <a:bodyPr wrap="square" anchor="t">
+          <a:bodyPr wrap="square" anchor="ctr">
             <a:spAutoFit/>
           </a:bodyPr>
           <a:lstStyle/>
           <a:p>
             <a:pPr algn="l">
               <a:spcAft>
-                <a:spcPts val="500"/>
-              </a:spcAft>
-            </a:pPr>
-            <a:r>
-              <a:rPr sz="1500" b="1">
+                <a:spcPts val="700"/>
+              </a:spcAft>
+            </a:pPr>
+            <a:r>
+              <a:rPr sz="1600" b="1">
                 <a:solidFill>
                   <a:srgbClr val="1F3A5F"/>
                 </a:solidFill>
@@ -7861,7 +7890,7 @@
           <a:p>
             <a:pPr algn="l" lvl="1">
               <a:spcAft>
-                <a:spcPts val="500"/>
+                <a:spcPts val="700"/>
               </a:spcAft>
             </a:pPr>
             <a:r>
@@ -7876,7 +7905,7 @@
           <a:p>
             <a:pPr algn="l" lvl="1">
               <a:spcAft>
-                <a:spcPts val="500"/>
+                <a:spcPts val="700"/>
               </a:spcAft>
             </a:pPr>
             <a:r>
@@ -7891,11 +7920,11 @@
           <a:p>
             <a:pPr algn="l">
               <a:spcAft>
-                <a:spcPts val="500"/>
-              </a:spcAft>
-            </a:pPr>
-            <a:r>
-              <a:rPr sz="1500" b="1">
+                <a:spcPts val="700"/>
+              </a:spcAft>
+            </a:pPr>
+            <a:r>
+              <a:rPr sz="1600" b="1">
                 <a:solidFill>
                   <a:srgbClr val="1F3A5F"/>
                 </a:solidFill>
@@ -7909,7 +7938,7 @@
           <a:p>
             <a:pPr algn="l" lvl="1">
               <a:spcAft>
-                <a:spcPts val="500"/>
+                <a:spcPts val="700"/>
               </a:spcAft>
             </a:pPr>
             <a:r>
@@ -7924,7 +7953,7 @@
           <a:p>
             <a:pPr algn="l" lvl="1">
               <a:spcAft>
-                <a:spcPts val="500"/>
+                <a:spcPts val="700"/>
               </a:spcAft>
             </a:pPr>
             <a:r>
@@ -7939,11 +7968,11 @@
           <a:p>
             <a:pPr algn="l">
               <a:spcAft>
-                <a:spcPts val="500"/>
-              </a:spcAft>
-            </a:pPr>
-            <a:r>
-              <a:rPr sz="1500" b="1">
+                <a:spcPts val="700"/>
+              </a:spcAft>
+            </a:pPr>
+            <a:r>
+              <a:rPr sz="1600" b="1">
                 <a:solidFill>
                   <a:srgbClr val="1F3A5F"/>
                 </a:solidFill>
@@ -7957,7 +7986,7 @@
           <a:p>
             <a:pPr algn="l" lvl="1">
               <a:spcAft>
-                <a:spcPts val="500"/>
+                <a:spcPts val="700"/>
               </a:spcAft>
             </a:pPr>
             <a:r>
@@ -7972,7 +8001,7 @@
           <a:p>
             <a:pPr algn="l" lvl="1">
               <a:spcAft>
-                <a:spcPts val="500"/>
+                <a:spcPts val="700"/>
               </a:spcAft>
             </a:pPr>
             <a:r>
@@ -8171,18 +8200,18 @@
           <a:noFill/>
         </p:spPr>
         <p:txBody>
-          <a:bodyPr wrap="square" anchor="t">
+          <a:bodyPr wrap="square" anchor="ctr">
             <a:spAutoFit/>
           </a:bodyPr>
           <a:lstStyle/>
           <a:p>
             <a:pPr algn="l">
               <a:spcAft>
-                <a:spcPts val="500"/>
-              </a:spcAft>
-            </a:pPr>
-            <a:r>
-              <a:rPr sz="1500" b="1">
+                <a:spcPts val="700"/>
+              </a:spcAft>
+            </a:pPr>
+            <a:r>
+              <a:rPr sz="1600" b="1">
                 <a:solidFill>
                   <a:srgbClr val="1F3A5F"/>
                 </a:solidFill>
@@ -8196,7 +8225,7 @@
           <a:p>
             <a:pPr algn="l" lvl="1">
               <a:spcAft>
-                <a:spcPts val="500"/>
+                <a:spcPts val="700"/>
               </a:spcAft>
             </a:pPr>
             <a:r>
@@ -8211,7 +8240,7 @@
           <a:p>
             <a:pPr algn="l" lvl="1">
               <a:spcAft>
-                <a:spcPts val="500"/>
+                <a:spcPts val="700"/>
               </a:spcAft>
             </a:pPr>
             <a:r>
@@ -8226,11 +8255,11 @@
           <a:p>
             <a:pPr algn="l">
               <a:spcAft>
-                <a:spcPts val="500"/>
-              </a:spcAft>
-            </a:pPr>
-            <a:r>
-              <a:rPr sz="1500" b="1">
+                <a:spcPts val="700"/>
+              </a:spcAft>
+            </a:pPr>
+            <a:r>
+              <a:rPr sz="1600" b="1">
                 <a:solidFill>
                   <a:srgbClr val="1F3A5F"/>
                 </a:solidFill>
@@ -8244,7 +8273,7 @@
           <a:p>
             <a:pPr algn="l" lvl="1">
               <a:spcAft>
-                <a:spcPts val="500"/>
+                <a:spcPts val="700"/>
               </a:spcAft>
             </a:pPr>
             <a:r>
@@ -8259,11 +8288,11 @@
           <a:p>
             <a:pPr algn="l">
               <a:spcAft>
-                <a:spcPts val="500"/>
-              </a:spcAft>
-            </a:pPr>
-            <a:r>
-              <a:rPr sz="1500" b="1">
+                <a:spcPts val="700"/>
+              </a:spcAft>
+            </a:pPr>
+            <a:r>
+              <a:rPr sz="1600" b="1">
                 <a:solidFill>
                   <a:srgbClr val="C7463B"/>
                 </a:solidFill>
@@ -8277,7 +8306,7 @@
           <a:p>
             <a:pPr algn="l" lvl="1">
               <a:spcAft>
-                <a:spcPts val="500"/>
+                <a:spcPts val="700"/>
               </a:spcAft>
             </a:pPr>
             <a:r>
@@ -8292,11 +8321,11 @@
           <a:p>
             <a:pPr algn="l">
               <a:spcAft>
-                <a:spcPts val="500"/>
-              </a:spcAft>
-            </a:pPr>
-            <a:r>
-              <a:rPr sz="1500" b="1">
+                <a:spcPts val="700"/>
+              </a:spcAft>
+            </a:pPr>
+            <a:r>
+              <a:rPr sz="1600" b="1">
                 <a:solidFill>
                   <a:srgbClr val="E9A23B"/>
                 </a:solidFill>
@@ -8310,7 +8339,7 @@
           <a:p>
             <a:pPr algn="l" lvl="1">
               <a:spcAft>
-                <a:spcPts val="500"/>
+                <a:spcPts val="700"/>
               </a:spcAft>
             </a:pPr>
             <a:r>
@@ -8325,7 +8354,7 @@
           <a:p>
             <a:pPr algn="l" lvl="1">
               <a:spcAft>
-                <a:spcPts val="500"/>
+                <a:spcPts val="700"/>
               </a:spcAft>
             </a:pPr>
             <a:r>
@@ -8625,7 +8654,7 @@
               </a:spcAft>
             </a:pPr>
             <a:r>
-              <a:rPr sz="1500" b="1">
+              <a:rPr sz="1600" b="1">
                 <a:solidFill>
                   <a:srgbClr val="1F3A5F"/>
                 </a:solidFill>
@@ -8810,7 +8839,7 @@
               </a:spcAft>
             </a:pPr>
             <a:r>
-              <a:rPr sz="1500" b="1">
+              <a:rPr sz="1600" b="1">
                 <a:solidFill>
                   <a:srgbClr val="1F3A5F"/>
                 </a:solidFill>
@@ -8995,7 +9024,7 @@
               </a:spcAft>
             </a:pPr>
             <a:r>
-              <a:rPr sz="1500" b="1">
+              <a:rPr sz="1600" b="1">
                 <a:solidFill>
                   <a:srgbClr val="1F3A5F"/>
                 </a:solidFill>
@@ -9180,7 +9209,7 @@
               </a:spcAft>
             </a:pPr>
             <a:r>
-              <a:rPr sz="1500" b="1">
+              <a:rPr sz="1600" b="1">
                 <a:solidFill>
                   <a:srgbClr val="1F3A5F"/>
                 </a:solidFill>
@@ -9432,18 +9461,18 @@
           <a:noFill/>
         </p:spPr>
         <p:txBody>
-          <a:bodyPr wrap="square" anchor="t">
+          <a:bodyPr wrap="square" anchor="ctr">
             <a:spAutoFit/>
           </a:bodyPr>
           <a:lstStyle/>
           <a:p>
             <a:pPr algn="l">
               <a:spcAft>
-                <a:spcPts val="500"/>
-              </a:spcAft>
-            </a:pPr>
-            <a:r>
-              <a:rPr sz="1500" b="1">
+                <a:spcPts val="700"/>
+              </a:spcAft>
+            </a:pPr>
+            <a:r>
+              <a:rPr sz="1600" b="1">
                 <a:solidFill>
                   <a:srgbClr val="1F3A5F"/>
                 </a:solidFill>
@@ -9457,7 +9486,7 @@
           <a:p>
             <a:pPr algn="l" lvl="1">
               <a:spcAft>
-                <a:spcPts val="500"/>
+                <a:spcPts val="700"/>
               </a:spcAft>
             </a:pPr>
             <a:r>
@@ -9472,7 +9501,7 @@
           <a:p>
             <a:pPr algn="l" lvl="1">
               <a:spcAft>
-                <a:spcPts val="500"/>
+                <a:spcPts val="700"/>
               </a:spcAft>
             </a:pPr>
             <a:r>
@@ -9487,7 +9516,7 @@
           <a:p>
             <a:pPr algn="l" lvl="1">
               <a:spcAft>
-                <a:spcPts val="500"/>
+                <a:spcPts val="700"/>
               </a:spcAft>
             </a:pPr>
             <a:r>
@@ -9502,11 +9531,11 @@
           <a:p>
             <a:pPr algn="l">
               <a:spcAft>
-                <a:spcPts val="500"/>
-              </a:spcAft>
-            </a:pPr>
-            <a:r>
-              <a:rPr sz="1500" b="1">
+                <a:spcPts val="700"/>
+              </a:spcAft>
+            </a:pPr>
+            <a:r>
+              <a:rPr sz="1600" b="1">
                 <a:solidFill>
                   <a:srgbClr val="2E86AB"/>
                 </a:solidFill>
@@ -9520,7 +9549,7 @@
           <a:p>
             <a:pPr algn="l" lvl="1">
               <a:spcAft>
-                <a:spcPts val="500"/>
+                <a:spcPts val="700"/>
               </a:spcAft>
             </a:pPr>
             <a:r>
@@ -9535,11 +9564,11 @@
           <a:p>
             <a:pPr algn="l">
               <a:spcAft>
-                <a:spcPts val="500"/>
-              </a:spcAft>
-            </a:pPr>
-            <a:r>
-              <a:rPr sz="1500" b="1">
+                <a:spcPts val="700"/>
+              </a:spcAft>
+            </a:pPr>
+            <a:r>
+              <a:rPr sz="1600" b="1">
                 <a:solidFill>
                   <a:srgbClr val="2E86AB"/>
                 </a:solidFill>
@@ -9553,7 +9582,7 @@
           <a:p>
             <a:pPr algn="l" lvl="1">
               <a:spcAft>
-                <a:spcPts val="500"/>
+                <a:spcPts val="700"/>
               </a:spcAft>
             </a:pPr>
             <a:r>
@@ -9752,14 +9781,14 @@
           <a:noFill/>
         </p:spPr>
         <p:txBody>
-          <a:bodyPr wrap="square" anchor="t">
+          <a:bodyPr wrap="square" anchor="ctr">
             <a:spAutoFit/>
           </a:bodyPr>
           <a:lstStyle/>
           <a:p>
             <a:pPr algn="l">
               <a:spcAft>
-                <a:spcPts val="500"/>
+                <a:spcPts val="600"/>
               </a:spcAft>
             </a:pPr>
             <a:r>
@@ -9985,7 +10014,7 @@
           <a:noFill/>
         </p:spPr>
         <p:txBody>
-          <a:bodyPr wrap="square" anchor="t">
+          <a:bodyPr wrap="square" anchor="ctr">
             <a:spAutoFit/>
           </a:bodyPr>
           <a:lstStyle/>
@@ -9996,7 +10025,7 @@
               </a:spcAft>
             </a:pPr>
             <a:r>
-              <a:rPr sz="1500" b="1">
+              <a:rPr sz="1600" b="1">
                 <a:solidFill>
                   <a:srgbClr val="1F3A5F"/>
                 </a:solidFill>
@@ -10014,7 +10043,7 @@
               </a:spcAft>
             </a:pPr>
             <a:r>
-              <a:rPr sz="1500" b="1">
+              <a:rPr sz="1600" b="1">
                 <a:solidFill>
                   <a:srgbClr val="1F3A5F"/>
                 </a:solidFill>
@@ -10032,7 +10061,7 @@
               </a:spcAft>
             </a:pPr>
             <a:r>
-              <a:rPr sz="1500" b="1">
+              <a:rPr sz="1600" b="1">
                 <a:solidFill>
                   <a:srgbClr val="1F3A5F"/>
                 </a:solidFill>
@@ -10050,7 +10079,7 @@
               </a:spcAft>
             </a:pPr>
             <a:r>
-              <a:rPr sz="1500" b="1">
+              <a:rPr sz="1600" b="1">
                 <a:solidFill>
                   <a:srgbClr val="1F3A5F"/>
                 </a:solidFill>
@@ -10064,7 +10093,7 @@
           <a:p>
             <a:pPr algn="l">
               <a:spcAft>
-                <a:spcPts val="500"/>
+                <a:spcPts val="700"/>
               </a:spcAft>
             </a:pPr>
             <a:r>
@@ -10367,7 +10396,7 @@
               </a:spcAft>
             </a:pPr>
             <a:r>
-              <a:rPr sz="1500" b="1">
+              <a:rPr sz="1600" b="1">
                 <a:solidFill>
                   <a:srgbClr val="1F3A5F"/>
                 </a:solidFill>
@@ -10552,7 +10581,7 @@
               </a:spcAft>
             </a:pPr>
             <a:r>
-              <a:rPr sz="1500" b="1">
+              <a:rPr sz="1600" b="1">
                 <a:solidFill>
                   <a:srgbClr val="1F3A5F"/>
                 </a:solidFill>
@@ -10737,7 +10766,7 @@
               </a:spcAft>
             </a:pPr>
             <a:r>
-              <a:rPr sz="1500" b="1">
+              <a:rPr sz="1600" b="1">
                 <a:solidFill>
                   <a:srgbClr val="1F3A5F"/>
                 </a:solidFill>
@@ -10922,7 +10951,7 @@
               </a:spcAft>
             </a:pPr>
             <a:r>
-              <a:rPr sz="1500" b="1">
+              <a:rPr sz="1600" b="1">
                 <a:solidFill>
                   <a:srgbClr val="1F3A5F"/>
                 </a:solidFill>
@@ -11107,7 +11136,7 @@
               </a:spcAft>
             </a:pPr>
             <a:r>
-              <a:rPr sz="1500" b="1">
+              <a:rPr sz="1600" b="1">
                 <a:solidFill>
                   <a:srgbClr val="1F3A5F"/>
                 </a:solidFill>
@@ -11292,7 +11321,7 @@
               </a:spcAft>
             </a:pPr>
             <a:r>
-              <a:rPr sz="1500" b="1">
+              <a:rPr sz="1600" b="1">
                 <a:solidFill>
                   <a:srgbClr val="1F3A5F"/>
                 </a:solidFill>
@@ -11810,18 +11839,18 @@
           <a:noFill/>
         </p:spPr>
         <p:txBody>
-          <a:bodyPr wrap="square" anchor="t">
+          <a:bodyPr wrap="square" anchor="ctr">
             <a:spAutoFit/>
           </a:bodyPr>
           <a:lstStyle/>
           <a:p>
             <a:pPr algn="l">
               <a:spcAft>
-                <a:spcPts val="500"/>
-              </a:spcAft>
-            </a:pPr>
-            <a:r>
-              <a:rPr sz="1500" b="1">
+                <a:spcPts val="700"/>
+              </a:spcAft>
+            </a:pPr>
+            <a:r>
+              <a:rPr sz="1600" b="1">
                 <a:solidFill>
                   <a:srgbClr val="1F3A5F"/>
                 </a:solidFill>
@@ -11835,7 +11864,7 @@
           <a:p>
             <a:pPr algn="l" lvl="1">
               <a:spcAft>
-                <a:spcPts val="500"/>
+                <a:spcPts val="700"/>
               </a:spcAft>
             </a:pPr>
             <a:r>
@@ -11850,11 +11879,11 @@
           <a:p>
             <a:pPr algn="l">
               <a:spcAft>
-                <a:spcPts val="500"/>
-              </a:spcAft>
-            </a:pPr>
-            <a:r>
-              <a:rPr sz="1500" b="1">
+                <a:spcPts val="700"/>
+              </a:spcAft>
+            </a:pPr>
+            <a:r>
+              <a:rPr sz="1600" b="1">
                 <a:solidFill>
                   <a:srgbClr val="1F3A5F"/>
                 </a:solidFill>
@@ -11868,7 +11897,7 @@
           <a:p>
             <a:pPr algn="l" lvl="1">
               <a:spcAft>
-                <a:spcPts val="500"/>
+                <a:spcPts val="700"/>
               </a:spcAft>
             </a:pPr>
             <a:r>
@@ -11883,11 +11912,11 @@
           <a:p>
             <a:pPr algn="l">
               <a:spcAft>
-                <a:spcPts val="500"/>
-              </a:spcAft>
-            </a:pPr>
-            <a:r>
-              <a:rPr sz="1500" b="1">
+                <a:spcPts val="700"/>
+              </a:spcAft>
+            </a:pPr>
+            <a:r>
+              <a:rPr sz="1600" b="1">
                 <a:solidFill>
                   <a:srgbClr val="1F3A5F"/>
                 </a:solidFill>
@@ -11901,7 +11930,7 @@
           <a:p>
             <a:pPr algn="l" lvl="1">
               <a:spcAft>
-                <a:spcPts val="500"/>
+                <a:spcPts val="700"/>
               </a:spcAft>
             </a:pPr>
             <a:r>
@@ -11916,11 +11945,11 @@
           <a:p>
             <a:pPr algn="l">
               <a:spcAft>
-                <a:spcPts val="500"/>
-              </a:spcAft>
-            </a:pPr>
-            <a:r>
-              <a:rPr sz="1500" b="1">
+                <a:spcPts val="700"/>
+              </a:spcAft>
+            </a:pPr>
+            <a:r>
+              <a:rPr sz="1600" b="1">
                 <a:solidFill>
                   <a:srgbClr val="1F3A5F"/>
                 </a:solidFill>
@@ -11934,7 +11963,7 @@
           <a:p>
             <a:pPr algn="l" lvl="1">
               <a:spcAft>
-                <a:spcPts val="500"/>
+                <a:spcPts val="700"/>
               </a:spcAft>
             </a:pPr>
             <a:r>
@@ -12133,18 +12162,18 @@
           <a:noFill/>
         </p:spPr>
         <p:txBody>
-          <a:bodyPr wrap="square" anchor="t">
+          <a:bodyPr wrap="square" anchor="ctr">
             <a:spAutoFit/>
           </a:bodyPr>
           <a:lstStyle/>
           <a:p>
             <a:pPr algn="l">
               <a:spcAft>
-                <a:spcPts val="500"/>
-              </a:spcAft>
-            </a:pPr>
-            <a:r>
-              <a:rPr sz="1500" b="1">
+                <a:spcPts val="700"/>
+              </a:spcAft>
+            </a:pPr>
+            <a:r>
+              <a:rPr sz="1600" b="1">
                 <a:solidFill>
                   <a:srgbClr val="1F3A5F"/>
                 </a:solidFill>
@@ -12158,7 +12187,7 @@
           <a:p>
             <a:pPr algn="l" lvl="1">
               <a:spcAft>
-                <a:spcPts val="500"/>
+                <a:spcPts val="700"/>
               </a:spcAft>
             </a:pPr>
             <a:r>
@@ -12173,11 +12202,11 @@
           <a:p>
             <a:pPr algn="l">
               <a:spcAft>
-                <a:spcPts val="500"/>
-              </a:spcAft>
-            </a:pPr>
-            <a:r>
-              <a:rPr sz="1500" b="1">
+                <a:spcPts val="700"/>
+              </a:spcAft>
+            </a:pPr>
+            <a:r>
+              <a:rPr sz="1600" b="1">
                 <a:solidFill>
                   <a:srgbClr val="1F3A5F"/>
                 </a:solidFill>
@@ -12191,7 +12220,7 @@
           <a:p>
             <a:pPr algn="l" lvl="1">
               <a:spcAft>
-                <a:spcPts val="500"/>
+                <a:spcPts val="700"/>
               </a:spcAft>
             </a:pPr>
             <a:r>
@@ -12206,11 +12235,11 @@
           <a:p>
             <a:pPr algn="l">
               <a:spcAft>
-                <a:spcPts val="500"/>
-              </a:spcAft>
-            </a:pPr>
-            <a:r>
-              <a:rPr sz="1500" b="1">
+                <a:spcPts val="700"/>
+              </a:spcAft>
+            </a:pPr>
+            <a:r>
+              <a:rPr sz="1600" b="1">
                 <a:solidFill>
                   <a:srgbClr val="1F3A5F"/>
                 </a:solidFill>
@@ -12224,7 +12253,7 @@
           <a:p>
             <a:pPr algn="l" lvl="1">
               <a:spcAft>
-                <a:spcPts val="500"/>
+                <a:spcPts val="700"/>
               </a:spcAft>
             </a:pPr>
             <a:r>
@@ -12239,11 +12268,11 @@
           <a:p>
             <a:pPr algn="l">
               <a:spcAft>
-                <a:spcPts val="500"/>
-              </a:spcAft>
-            </a:pPr>
-            <a:r>
-              <a:rPr sz="1500" b="1">
+                <a:spcPts val="700"/>
+              </a:spcAft>
+            </a:pPr>
+            <a:r>
+              <a:rPr sz="1600" b="1">
                 <a:solidFill>
                   <a:srgbClr val="1F3A5F"/>
                 </a:solidFill>
@@ -12257,7 +12286,7 @@
           <a:p>
             <a:pPr algn="l" lvl="1">
               <a:spcAft>
-                <a:spcPts val="500"/>
+                <a:spcPts val="700"/>
               </a:spcAft>
             </a:pPr>
             <a:r>
@@ -12456,7 +12485,7 @@
           <a:noFill/>
         </p:spPr>
         <p:txBody>
-          <a:bodyPr wrap="square" anchor="t">
+          <a:bodyPr wrap="square" anchor="ctr">
             <a:spAutoFit/>
           </a:bodyPr>
           <a:lstStyle/>
@@ -12496,7 +12525,7 @@
           <a:p>
             <a:pPr algn="l" lvl="1">
               <a:spcAft>
-                <a:spcPts val="500"/>
+                <a:spcPts val="600"/>
               </a:spcAft>
             </a:pPr>
             <a:r>
@@ -12514,7 +12543,7 @@
           <a:p>
             <a:pPr algn="l" lvl="1">
               <a:spcAft>
-                <a:spcPts val="500"/>
+                <a:spcPts val="600"/>
               </a:spcAft>
             </a:pPr>
             <a:r>
@@ -12529,7 +12558,7 @@
           <a:p>
             <a:pPr algn="l">
               <a:spcAft>
-                <a:spcPts val="500"/>
+                <a:spcPts val="600"/>
               </a:spcAft>
             </a:pPr>
             <a:r>
@@ -12755,7 +12784,7 @@
           <a:noFill/>
         </p:spPr>
         <p:txBody>
-          <a:bodyPr wrap="square" anchor="t">
+          <a:bodyPr wrap="square" anchor="ctr">
             <a:spAutoFit/>
           </a:bodyPr>
           <a:lstStyle/>
@@ -12798,11 +12827,11 @@
           <a:p>
             <a:pPr algn="l">
               <a:spcAft>
-                <a:spcPts val="500"/>
-              </a:spcAft>
-            </a:pPr>
-            <a:r>
-              <a:rPr sz="1500" b="1">
+                <a:spcPts val="700"/>
+              </a:spcAft>
+            </a:pPr>
+            <a:r>
+              <a:rPr sz="1600" b="1">
                 <a:solidFill>
                   <a:srgbClr val="C7463B"/>
                 </a:solidFill>
@@ -12816,11 +12845,11 @@
           <a:p>
             <a:pPr algn="l" lvl="1">
               <a:spcAft>
-                <a:spcPts val="500"/>
-              </a:spcAft>
-            </a:pPr>
-            <a:r>
-              <a:rPr sz="1500" b="1">
+                <a:spcPts val="700"/>
+              </a:spcAft>
+            </a:pPr>
+            <a:r>
+              <a:rPr sz="1600" b="1">
                 <a:solidFill>
                   <a:srgbClr val="C7463B"/>
                 </a:solidFill>
@@ -12834,11 +12863,11 @@
           <a:p>
             <a:pPr algn="l" lvl="1">
               <a:spcAft>
-                <a:spcPts val="500"/>
-              </a:spcAft>
-            </a:pPr>
-            <a:r>
-              <a:rPr sz="1500" b="1">
+                <a:spcPts val="700"/>
+              </a:spcAft>
+            </a:pPr>
+            <a:r>
+              <a:rPr sz="1600" b="1">
                 <a:solidFill>
                   <a:srgbClr val="C7463B"/>
                 </a:solidFill>
@@ -13036,7 +13065,7 @@
           <a:noFill/>
         </p:spPr>
         <p:txBody>
-          <a:bodyPr wrap="square" anchor="t">
+          <a:bodyPr wrap="square" anchor="ctr">
             <a:spAutoFit/>
           </a:bodyPr>
           <a:lstStyle/>
@@ -13061,7 +13090,7 @@
           <a:p>
             <a:pPr algn="l" lvl="1">
               <a:spcAft>
-                <a:spcPts val="500"/>
+                <a:spcPts val="700"/>
               </a:spcAft>
             </a:pPr>
             <a:r>
@@ -13076,7 +13105,7 @@
           <a:p>
             <a:pPr algn="l" lvl="1">
               <a:spcAft>
-                <a:spcPts val="500"/>
+                <a:spcPts val="700"/>
               </a:spcAft>
             </a:pPr>
             <a:r>
@@ -13091,7 +13120,7 @@
           <a:p>
             <a:pPr algn="l">
               <a:spcAft>
-                <a:spcPts val="500"/>
+                <a:spcPts val="700"/>
               </a:spcAft>
             </a:pPr>
             <a:r>

</xml_diff>